<commit_message>
Slide 9: full-width interval chart
Co-Authored-By: Claude Opus 5.5 <noreply@anthropic.com>
</commit_message>
<xml_diff>
--- a/reports/presentation_draft.pptx
+++ b/reports/presentation_draft.pptx
@@ -1313,6 +1313,54 @@
           <a:lstStyle/>
           <a:p>
             <a:r>
+              <a:t>Новогодние матчи 26–30.12 (Металлург Мг, Лада, Барыс) — ранний спрос, как в прошлые Новые годы. Продано уже 51–59% мест, в 1,6–2,1 раза быстрее обычного матча. Но прошлые новогодние матчи к той же дате были проданы на 58–68% (4 из 5) и закончили на 66–72%: спрос приходит раньше, но не больше. В этом году к той же дате продано меньше, чем в прошлые Новые годы. По новогодней кривой итог был бы 56–63%, модель ставит 73–77% — она учитывает, что сезон 2025/26 в целом заполненнее (70% против 63–66%). Аналогия построена на 5 матчах, поэтому риск отклонения в обе стороны, скорее в сторону переоценки. Прогноз модели не правили, чтобы не подгонять под 5 матчей.</a:t>
+            </a:r>
+          </a:p>
+          <a:p/>
+          <a:p>
+            <a:r>
+              <a:t>Прошлые Новые годы (продано к той же дате, за 11–15 дней до матча, как у M087–M089 на 15.12 | итог):</a:t>
+            </a:r>
+          </a:p>
+          <a:p>
+            <a:r>
+              <a:t>M023, 24.12.2023: 58–62% | 70%</a:t>
+            </a:r>
+          </a:p>
+          <a:p>
+            <a:r>
+              <a:t>M024, 03.01.2024: 64–68% | 72%</a:t>
+            </a:r>
+          </a:p>
+          <a:p>
+            <a:r>
+              <a:t>M025, 06.01.2024: 62–66% | 71%</a:t>
+            </a:r>
+          </a:p>
+          <a:p>
+            <a:r>
+              <a:t>M055, 28.12.2024: 39–48% | 70%</a:t>
+            </a:r>
+          </a:p>
+          <a:p>
+            <a:r>
+              <a:t>M056, 30.12.2024: 60–62% | 66%</a:t>
+            </a:r>
+          </a:p>
+          <a:p>
+            <a:r>
+              <a:t>2025/26, M087–M089: 51–59% | прогноз 73–77%</a:t>
+            </a:r>
+          </a:p>
+          <a:p/>
+          <a:p>
+            <a:r>
+              <a:t>Ни один матч и ни одна зона не выходят за исторические пределы и не упираются в число свободных мест.</a:t>
+            </a:r>
+          </a:p>
+          <a:p/>
+          <a:p>
+            <a:r>
               <a:t>«На новогодние матчи уже продано больше половины мест, и наши флаги на это срабатывают: обычный матч к этому дню продан вдвое меньше. Но прошлые Новые годы показывают, что это ранний спрос, а не больший: к той же дате четыре из пяти были проданы даже сильнее, чем сейчас, и все и закончили на 66–72%. Модель ставит выше, потому что сезон в целом заполненнее. Мы её не правили вручную — пять матчей слишком мало, чтобы подгонять под них прогноз, — но если ошибёмся, то скорее вверх».</a:t>
             </a:r>
           </a:p>
@@ -1326,12 +1374,6 @@
           <a:p>
             <a:r>
               <a:t>Источники: solution.ipynb → Сохранение (сумма); 04_report.ipynb → 1.1 (среднее сезона), 1.2 (темп и проданное), 1.3, 1.4 (флаги и пояснение), 1.5 (прошлые Новые годы), 2.4, 4.3–4.4 (интервалы).</a:t>
-            </a:r>
-          </a:p>
-          <a:p/>
-          <a:p>
-            <a:r>
-              <a:t>«Продано к той же дате» — за 11–15 дней до матча, как у M087–M089 на 15.12.</a:t>
             </a:r>
           </a:p>
         </p:txBody>
@@ -4500,7 +4542,7 @@
         <p:spPr>
           <a:xfrm>
             <a:off x="548640" y="1234440"/>
-            <a:ext cx="6878537" cy="5166360"/>
+            <a:ext cx="11094415" cy="5166360"/>
           </a:xfrm>
           <a:prstGeom prst="rect">
             <a:avLst/>
@@ -4581,55 +4623,7 @@
                 </a:solidFill>
                 <a:latin typeface="Calibri"/>
               </a:rPr>
-              <a:t>Ни один матч и ни одна зона не выходят за исторические пределы и не упираются в число свободных мест.</a:t>
-            </a:r>
-          </a:p>
-          <a:p>
-            <a:pPr marL="274320" indent="-274320">
-              <a:lnSpc>
-                <a:spcPct val="100000"/>
-              </a:lnSpc>
-              <a:spcAft>
-                <a:spcPts val="800"/>
-              </a:spcAft>
-              <a:buClr>
-                <a:srgbClr val="B5121B"/>
-              </a:buClr>
-              <a:buFont typeface="Arial"/>
-              <a:buChar char="•"/>
-            </a:pPr>
-            <a:r>
-              <a:rPr sz="1800" b="0">
-                <a:solidFill>
-                  <a:srgbClr val="1F1F1F"/>
-                </a:solidFill>
-                <a:latin typeface="Calibri"/>
-              </a:rPr>
-              <a:t>Новогодние матчи 26–30.12 (Металлург Мг, Лада, Барыс) — ранний спрос, как в прошлые Новые годы. Продано уже 51–59% мест, в 1,6–2,1 раза быстрее обычного матча. Но прошлые новогодние матчи к той же дате были проданы на 58–68% (4 из 5) и закончили на 66–72%: спрос приходит раньше, но не больше.</a:t>
-            </a:r>
-          </a:p>
-          <a:p>
-            <a:pPr marL="274320" indent="-274320">
-              <a:lnSpc>
-                <a:spcPct val="100000"/>
-              </a:lnSpc>
-              <a:spcAft>
-                <a:spcPts val="800"/>
-              </a:spcAft>
-              <a:buClr>
-                <a:srgbClr val="B5121B"/>
-              </a:buClr>
-              <a:buFont typeface="Arial"/>
-              <a:buChar char="•"/>
-            </a:pPr>
-            <a:r>
-              <a:rPr sz="1800" b="0">
-                <a:solidFill>
-                  <a:srgbClr val="1F1F1F"/>
-                </a:solidFill>
-                <a:latin typeface="Calibri"/>
-              </a:rPr>
-              <a:t>В этом году к той же дате продано меньше, чем в прошлые Новые годы. По новогодней кривой итог был бы 56–63%, модель ставит 73–77%: она учитывает, что сезон 2025/26 заполненнее (70% против 63–66%). Аналогия — всего 5 матчей: риск в обе стороны, скорее переоценка; прогноз не правили, чтобы не подгонять под них.</a:t>
+              <a:t>Новогодние матчи 26–30.12 продаются раньше, но не больше: прошлые Новые годы закончили на 66–72% мест, модель ставит 73–77% — риск скорее в сторону переоценки.</a:t>
             </a:r>
           </a:p>
         </p:txBody>
@@ -4650,541 +4644,17 @@
         </p:blipFill>
         <p:spPr>
           <a:xfrm>
-            <a:off x="7701497" y="1234440"/>
-            <a:ext cx="3941557" cy="2054135"/>
+            <a:off x="3176408" y="3357880"/>
+            <a:ext cx="5838878" cy="3042920"/>
           </a:xfrm>
           <a:prstGeom prst="rect">
             <a:avLst/>
           </a:prstGeom>
         </p:spPr>
       </p:pic>
-      <p:graphicFrame>
-        <p:nvGraphicFramePr>
-          <p:cNvPr id="5" name="Table 4"/>
-          <p:cNvGraphicFramePr>
-            <a:graphicFrameLocks noGrp="1"/>
-          </p:cNvGraphicFramePr>
-          <p:nvPr/>
-        </p:nvGraphicFramePr>
-        <p:xfrm>
-          <a:off x="7701497" y="3562895"/>
-          <a:ext cx="3941556" cy="2688336"/>
-        </p:xfrm>
-        <a:graphic>
-          <a:graphicData uri="http://schemas.openxmlformats.org/drawingml/2006/table">
-            <a:tbl>
-              <a:tblPr firstRow="0" bandRow="0">
-                <a:tableStyleId>{5C22544A-7EE6-4342-B048-85BDC9FD1C3A}</a:tableStyleId>
-              </a:tblPr>
-              <a:tblGrid>
-                <a:gridCol w="1883195"/>
-                <a:gridCol w="1073295"/>
-                <a:gridCol w="985066"/>
-              </a:tblGrid>
-              <a:tr h="536448">
-                <a:tc>
-                  <a:txBody>
-                    <a:bodyPr wrap="square"/>
-                    <a:lstStyle/>
-                    <a:p>
-                      <a:pPr algn="l"/>
-                      <a:r>
-                        <a:rPr sz="1400" b="1">
-                          <a:solidFill>
-                            <a:srgbClr val="1F1F1F"/>
-                          </a:solidFill>
-                          <a:latin typeface="Calibri"/>
-                        </a:rPr>
-                        <a:t>Матч</a:t>
-                      </a:r>
-                    </a:p>
-                  </a:txBody>
-                  <a:tcPr marL="54864" marR="54864" marT="36576" marB="36576" anchor="ctr">
-                    <a:solidFill>
-                      <a:srgbClr val="F5F2F2"/>
-                    </a:solidFill>
-                  </a:tcPr>
-                </a:tc>
-                <a:tc>
-                  <a:txBody>
-                    <a:bodyPr wrap="square"/>
-                    <a:lstStyle/>
-                    <a:p>
-                      <a:pPr algn="ctr"/>
-                      <a:r>
-                        <a:rPr sz="1400" b="1">
-                          <a:solidFill>
-                            <a:srgbClr val="1F1F1F"/>
-                          </a:solidFill>
-                          <a:latin typeface="Calibri"/>
-                        </a:rPr>
-                        <a:t>Продано к той же дате</a:t>
-                      </a:r>
-                    </a:p>
-                  </a:txBody>
-                  <a:tcPr marL="54864" marR="54864" marT="36576" marB="36576" anchor="ctr">
-                    <a:solidFill>
-                      <a:srgbClr val="F5F2F2"/>
-                    </a:solidFill>
-                  </a:tcPr>
-                </a:tc>
-                <a:tc>
-                  <a:txBody>
-                    <a:bodyPr wrap="square"/>
-                    <a:lstStyle/>
-                    <a:p>
-                      <a:pPr algn="ctr"/>
-                      <a:r>
-                        <a:rPr sz="1400" b="1">
-                          <a:solidFill>
-                            <a:srgbClr val="1F1F1F"/>
-                          </a:solidFill>
-                          <a:latin typeface="Calibri"/>
-                        </a:rPr>
-                        <a:t>Итог</a:t>
-                      </a:r>
-                    </a:p>
-                  </a:txBody>
-                  <a:tcPr marL="54864" marR="54864" marT="36576" marB="36576" anchor="ctr">
-                    <a:solidFill>
-                      <a:srgbClr val="F5F2F2"/>
-                    </a:solidFill>
-                  </a:tcPr>
-                </a:tc>
-              </a:tr>
-              <a:tr h="323088">
-                <a:tc>
-                  <a:txBody>
-                    <a:bodyPr wrap="square"/>
-                    <a:lstStyle/>
-                    <a:p>
-                      <a:pPr algn="l"/>
-                      <a:r>
-                        <a:rPr sz="1400" b="0">
-                          <a:solidFill>
-                            <a:srgbClr val="1F1F1F"/>
-                          </a:solidFill>
-                          <a:latin typeface="Calibri"/>
-                        </a:rPr>
-                        <a:t>M023, 24.12.2023</a:t>
-                      </a:r>
-                    </a:p>
-                  </a:txBody>
-                  <a:tcPr marL="54864" marR="54864" marT="36576" marB="36576" anchor="ctr">
-                    <a:solidFill>
-                      <a:srgbClr val="FFFFFF"/>
-                    </a:solidFill>
-                  </a:tcPr>
-                </a:tc>
-                <a:tc>
-                  <a:txBody>
-                    <a:bodyPr wrap="square"/>
-                    <a:lstStyle/>
-                    <a:p>
-                      <a:pPr algn="ctr"/>
-                      <a:r>
-                        <a:rPr sz="1400" b="0">
-                          <a:solidFill>
-                            <a:srgbClr val="1F1F1F"/>
-                          </a:solidFill>
-                          <a:latin typeface="Calibri"/>
-                        </a:rPr>
-                        <a:t>58–62%</a:t>
-                      </a:r>
-                    </a:p>
-                  </a:txBody>
-                  <a:tcPr marL="54864" marR="54864" marT="36576" marB="36576" anchor="ctr">
-                    <a:solidFill>
-                      <a:srgbClr val="FFFFFF"/>
-                    </a:solidFill>
-                  </a:tcPr>
-                </a:tc>
-                <a:tc>
-                  <a:txBody>
-                    <a:bodyPr wrap="square"/>
-                    <a:lstStyle/>
-                    <a:p>
-                      <a:pPr algn="ctr"/>
-                      <a:r>
-                        <a:rPr sz="1400" b="0">
-                          <a:solidFill>
-                            <a:srgbClr val="1F1F1F"/>
-                          </a:solidFill>
-                          <a:latin typeface="Calibri"/>
-                        </a:rPr>
-                        <a:t>70%</a:t>
-                      </a:r>
-                    </a:p>
-                  </a:txBody>
-                  <a:tcPr marL="54864" marR="54864" marT="36576" marB="36576" anchor="ctr">
-                    <a:solidFill>
-                      <a:srgbClr val="FFFFFF"/>
-                    </a:solidFill>
-                  </a:tcPr>
-                </a:tc>
-              </a:tr>
-              <a:tr h="323088">
-                <a:tc>
-                  <a:txBody>
-                    <a:bodyPr wrap="square"/>
-                    <a:lstStyle/>
-                    <a:p>
-                      <a:pPr algn="l"/>
-                      <a:r>
-                        <a:rPr sz="1400" b="0">
-                          <a:solidFill>
-                            <a:srgbClr val="1F1F1F"/>
-                          </a:solidFill>
-                          <a:latin typeface="Calibri"/>
-                        </a:rPr>
-                        <a:t>M024, 03.01.2024</a:t>
-                      </a:r>
-                    </a:p>
-                  </a:txBody>
-                  <a:tcPr marL="54864" marR="54864" marT="36576" marB="36576" anchor="ctr">
-                    <a:solidFill>
-                      <a:srgbClr val="FFFFFF"/>
-                    </a:solidFill>
-                  </a:tcPr>
-                </a:tc>
-                <a:tc>
-                  <a:txBody>
-                    <a:bodyPr wrap="square"/>
-                    <a:lstStyle/>
-                    <a:p>
-                      <a:pPr algn="ctr"/>
-                      <a:r>
-                        <a:rPr sz="1400" b="0">
-                          <a:solidFill>
-                            <a:srgbClr val="1F1F1F"/>
-                          </a:solidFill>
-                          <a:latin typeface="Calibri"/>
-                        </a:rPr>
-                        <a:t>64–68%</a:t>
-                      </a:r>
-                    </a:p>
-                  </a:txBody>
-                  <a:tcPr marL="54864" marR="54864" marT="36576" marB="36576" anchor="ctr">
-                    <a:solidFill>
-                      <a:srgbClr val="FFFFFF"/>
-                    </a:solidFill>
-                  </a:tcPr>
-                </a:tc>
-                <a:tc>
-                  <a:txBody>
-                    <a:bodyPr wrap="square"/>
-                    <a:lstStyle/>
-                    <a:p>
-                      <a:pPr algn="ctr"/>
-                      <a:r>
-                        <a:rPr sz="1400" b="0">
-                          <a:solidFill>
-                            <a:srgbClr val="1F1F1F"/>
-                          </a:solidFill>
-                          <a:latin typeface="Calibri"/>
-                        </a:rPr>
-                        <a:t>72%</a:t>
-                      </a:r>
-                    </a:p>
-                  </a:txBody>
-                  <a:tcPr marL="54864" marR="54864" marT="36576" marB="36576" anchor="ctr">
-                    <a:solidFill>
-                      <a:srgbClr val="FFFFFF"/>
-                    </a:solidFill>
-                  </a:tcPr>
-                </a:tc>
-              </a:tr>
-              <a:tr h="323088">
-                <a:tc>
-                  <a:txBody>
-                    <a:bodyPr wrap="square"/>
-                    <a:lstStyle/>
-                    <a:p>
-                      <a:pPr algn="l"/>
-                      <a:r>
-                        <a:rPr sz="1400" b="0">
-                          <a:solidFill>
-                            <a:srgbClr val="1F1F1F"/>
-                          </a:solidFill>
-                          <a:latin typeface="Calibri"/>
-                        </a:rPr>
-                        <a:t>M025, 06.01.2024</a:t>
-                      </a:r>
-                    </a:p>
-                  </a:txBody>
-                  <a:tcPr marL="54864" marR="54864" marT="36576" marB="36576" anchor="ctr">
-                    <a:solidFill>
-                      <a:srgbClr val="FFFFFF"/>
-                    </a:solidFill>
-                  </a:tcPr>
-                </a:tc>
-                <a:tc>
-                  <a:txBody>
-                    <a:bodyPr wrap="square"/>
-                    <a:lstStyle/>
-                    <a:p>
-                      <a:pPr algn="ctr"/>
-                      <a:r>
-                        <a:rPr sz="1400" b="0">
-                          <a:solidFill>
-                            <a:srgbClr val="1F1F1F"/>
-                          </a:solidFill>
-                          <a:latin typeface="Calibri"/>
-                        </a:rPr>
-                        <a:t>62–66%</a:t>
-                      </a:r>
-                    </a:p>
-                  </a:txBody>
-                  <a:tcPr marL="54864" marR="54864" marT="36576" marB="36576" anchor="ctr">
-                    <a:solidFill>
-                      <a:srgbClr val="FFFFFF"/>
-                    </a:solidFill>
-                  </a:tcPr>
-                </a:tc>
-                <a:tc>
-                  <a:txBody>
-                    <a:bodyPr wrap="square"/>
-                    <a:lstStyle/>
-                    <a:p>
-                      <a:pPr algn="ctr"/>
-                      <a:r>
-                        <a:rPr sz="1400" b="0">
-                          <a:solidFill>
-                            <a:srgbClr val="1F1F1F"/>
-                          </a:solidFill>
-                          <a:latin typeface="Calibri"/>
-                        </a:rPr>
-                        <a:t>71%</a:t>
-                      </a:r>
-                    </a:p>
-                  </a:txBody>
-                  <a:tcPr marL="54864" marR="54864" marT="36576" marB="36576" anchor="ctr">
-                    <a:solidFill>
-                      <a:srgbClr val="FFFFFF"/>
-                    </a:solidFill>
-                  </a:tcPr>
-                </a:tc>
-              </a:tr>
-              <a:tr h="323088">
-                <a:tc>
-                  <a:txBody>
-                    <a:bodyPr wrap="square"/>
-                    <a:lstStyle/>
-                    <a:p>
-                      <a:pPr algn="l"/>
-                      <a:r>
-                        <a:rPr sz="1400" b="0">
-                          <a:solidFill>
-                            <a:srgbClr val="1F1F1F"/>
-                          </a:solidFill>
-                          <a:latin typeface="Calibri"/>
-                        </a:rPr>
-                        <a:t>M055, 28.12.2024</a:t>
-                      </a:r>
-                    </a:p>
-                  </a:txBody>
-                  <a:tcPr marL="54864" marR="54864" marT="36576" marB="36576" anchor="ctr">
-                    <a:solidFill>
-                      <a:srgbClr val="FFFFFF"/>
-                    </a:solidFill>
-                  </a:tcPr>
-                </a:tc>
-                <a:tc>
-                  <a:txBody>
-                    <a:bodyPr wrap="square"/>
-                    <a:lstStyle/>
-                    <a:p>
-                      <a:pPr algn="ctr"/>
-                      <a:r>
-                        <a:rPr sz="1400" b="0">
-                          <a:solidFill>
-                            <a:srgbClr val="1F1F1F"/>
-                          </a:solidFill>
-                          <a:latin typeface="Calibri"/>
-                        </a:rPr>
-                        <a:t>39–48%</a:t>
-                      </a:r>
-                    </a:p>
-                  </a:txBody>
-                  <a:tcPr marL="54864" marR="54864" marT="36576" marB="36576" anchor="ctr">
-                    <a:solidFill>
-                      <a:srgbClr val="FFFFFF"/>
-                    </a:solidFill>
-                  </a:tcPr>
-                </a:tc>
-                <a:tc>
-                  <a:txBody>
-                    <a:bodyPr wrap="square"/>
-                    <a:lstStyle/>
-                    <a:p>
-                      <a:pPr algn="ctr"/>
-                      <a:r>
-                        <a:rPr sz="1400" b="0">
-                          <a:solidFill>
-                            <a:srgbClr val="1F1F1F"/>
-                          </a:solidFill>
-                          <a:latin typeface="Calibri"/>
-                        </a:rPr>
-                        <a:t>70%</a:t>
-                      </a:r>
-                    </a:p>
-                  </a:txBody>
-                  <a:tcPr marL="54864" marR="54864" marT="36576" marB="36576" anchor="ctr">
-                    <a:solidFill>
-                      <a:srgbClr val="FFFFFF"/>
-                    </a:solidFill>
-                  </a:tcPr>
-                </a:tc>
-              </a:tr>
-              <a:tr h="323088">
-                <a:tc>
-                  <a:txBody>
-                    <a:bodyPr wrap="square"/>
-                    <a:lstStyle/>
-                    <a:p>
-                      <a:pPr algn="l"/>
-                      <a:r>
-                        <a:rPr sz="1400" b="0">
-                          <a:solidFill>
-                            <a:srgbClr val="1F1F1F"/>
-                          </a:solidFill>
-                          <a:latin typeface="Calibri"/>
-                        </a:rPr>
-                        <a:t>M056, 30.12.2024</a:t>
-                      </a:r>
-                    </a:p>
-                  </a:txBody>
-                  <a:tcPr marL="54864" marR="54864" marT="36576" marB="36576" anchor="ctr">
-                    <a:solidFill>
-                      <a:srgbClr val="FFFFFF"/>
-                    </a:solidFill>
-                  </a:tcPr>
-                </a:tc>
-                <a:tc>
-                  <a:txBody>
-                    <a:bodyPr wrap="square"/>
-                    <a:lstStyle/>
-                    <a:p>
-                      <a:pPr algn="ctr"/>
-                      <a:r>
-                        <a:rPr sz="1400" b="0">
-                          <a:solidFill>
-                            <a:srgbClr val="1F1F1F"/>
-                          </a:solidFill>
-                          <a:latin typeface="Calibri"/>
-                        </a:rPr>
-                        <a:t>60–62%</a:t>
-                      </a:r>
-                    </a:p>
-                  </a:txBody>
-                  <a:tcPr marL="54864" marR="54864" marT="36576" marB="36576" anchor="ctr">
-                    <a:solidFill>
-                      <a:srgbClr val="FFFFFF"/>
-                    </a:solidFill>
-                  </a:tcPr>
-                </a:tc>
-                <a:tc>
-                  <a:txBody>
-                    <a:bodyPr wrap="square"/>
-                    <a:lstStyle/>
-                    <a:p>
-                      <a:pPr algn="ctr"/>
-                      <a:r>
-                        <a:rPr sz="1400" b="0">
-                          <a:solidFill>
-                            <a:srgbClr val="1F1F1F"/>
-                          </a:solidFill>
-                          <a:latin typeface="Calibri"/>
-                        </a:rPr>
-                        <a:t>66%</a:t>
-                      </a:r>
-                    </a:p>
-                  </a:txBody>
-                  <a:tcPr marL="54864" marR="54864" marT="36576" marB="36576" anchor="ctr">
-                    <a:solidFill>
-                      <a:srgbClr val="FFFFFF"/>
-                    </a:solidFill>
-                  </a:tcPr>
-                </a:tc>
-              </a:tr>
-              <a:tr h="536448">
-                <a:tc>
-                  <a:txBody>
-                    <a:bodyPr wrap="square"/>
-                    <a:lstStyle/>
-                    <a:p>
-                      <a:pPr algn="l"/>
-                      <a:r>
-                        <a:rPr sz="1400" b="1">
-                          <a:solidFill>
-                            <a:srgbClr val="1F1F1F"/>
-                          </a:solidFill>
-                          <a:latin typeface="Calibri"/>
-                        </a:rPr>
-                        <a:t>2025/26: M087–M089</a:t>
-                      </a:r>
-                    </a:p>
-                  </a:txBody>
-                  <a:tcPr marL="54864" marR="54864" marT="36576" marB="36576" anchor="ctr">
-                    <a:solidFill>
-                      <a:srgbClr val="FFFFFF"/>
-                    </a:solidFill>
-                  </a:tcPr>
-                </a:tc>
-                <a:tc>
-                  <a:txBody>
-                    <a:bodyPr wrap="square"/>
-                    <a:lstStyle/>
-                    <a:p>
-                      <a:pPr algn="ctr"/>
-                      <a:r>
-                        <a:rPr sz="1400" b="1">
-                          <a:solidFill>
-                            <a:srgbClr val="1F1F1F"/>
-                          </a:solidFill>
-                          <a:latin typeface="Calibri"/>
-                        </a:rPr>
-                        <a:t>51–59%</a:t>
-                      </a:r>
-                    </a:p>
-                  </a:txBody>
-                  <a:tcPr marL="54864" marR="54864" marT="36576" marB="36576" anchor="ctr">
-                    <a:solidFill>
-                      <a:srgbClr val="FFFFFF"/>
-                    </a:solidFill>
-                  </a:tcPr>
-                </a:tc>
-                <a:tc>
-                  <a:txBody>
-                    <a:bodyPr wrap="square"/>
-                    <a:lstStyle/>
-                    <a:p>
-                      <a:pPr algn="ctr"/>
-                      <a:r>
-                        <a:rPr sz="1400" b="1">
-                          <a:solidFill>
-                            <a:srgbClr val="1F1F1F"/>
-                          </a:solidFill>
-                          <a:latin typeface="Calibri"/>
-                        </a:rPr>
-                        <a:t>прогноз 73–77%</a:t>
-                      </a:r>
-                    </a:p>
-                  </a:txBody>
-                  <a:tcPr marL="54864" marR="54864" marT="36576" marB="36576" anchor="ctr">
-                    <a:solidFill>
-                      <a:srgbClr val="FFFFFF"/>
-                    </a:solidFill>
-                  </a:tcPr>
-                </a:tc>
-              </a:tr>
-            </a:tbl>
-          </a:graphicData>
-        </a:graphic>
-      </p:graphicFrame>
-      <p:sp>
-        <p:nvSpPr>
-          <p:cNvPr id="6" name="TextBox 5"/>
+      <p:sp>
+        <p:nvSpPr>
+          <p:cNvPr id="5" name="TextBox 4"/>
           <p:cNvSpPr txBox="1"/>
           <p:nvPr/>
         </p:nvSpPr>

</xml_diff>

<commit_message>
Figure 07: cleaner for slide
Co-Authored-By: Claude Opus 5.5 <noreply@anthropic.com>
</commit_message>
<xml_diff>
--- a/reports/presentation_draft.pptx
+++ b/reports/presentation_draft.pptx
@@ -4644,8 +4644,8 @@
         </p:blipFill>
         <p:spPr>
           <a:xfrm>
-            <a:off x="3176408" y="3357880"/>
-            <a:ext cx="5838878" cy="3042920"/>
+            <a:off x="2949226" y="3357880"/>
+            <a:ext cx="6293241" cy="3042920"/>
           </a:xfrm>
           <a:prstGeom prst="rect">
             <a:avLst/>

</xml_diff>

<commit_message>
Figure 07 at slide size
Co-Authored-By: Claude Opus 5.5 <noreply@anthropic.com>
</commit_message>
<xml_diff>
--- a/reports/presentation_draft.pptx
+++ b/reports/presentation_draft.pptx
@@ -1367,7 +1367,7 @@
           <a:p/>
           <a:p>
             <a:r>
-              <a:t>На графике: столбик — уже продано на 15.12, точка — прогноз CatBoost, отрезок — интервал 10–90% на матч; жирные даты — матчи в продаже. Интервал на матч — сумма зональных интервалов (квантили 10/90% остатков CatBoost на валидации по группам зон {1,2,8} / {3,4,5} / {6,7} и статусу продаж). Честная проверка leave-one-fold-out: накрыл 38 из 43 матчей (88%) при номинале 80%. Ширина — 35% прогноза у матчей в продаже, 42% у остальных. Прямой интервал по остатку суммы матча вдвое уже, но накрыл только 26 из 43 (60%): не учитывает межсезонный сдвиг. Зональные интервалы — ориентир: покрытие 69% при номинале 80%. «71–105 тыс.» — сумма нижних и верхних границ по 17 матчам. График без интервалов, с линией среднего сезона — reports/figures/04_test_forecast.png, показать по вопросу.</a:t>
+              <a:t>На графике: столбик — уже продано на 15.12, точка — прогноз CatBoost, отрезок — интервал 10–90% на матч; жирные даты — матчи в продаже. Соперники по датам: 24.12 Нефтехимик; 26.12 Металлург Мг; 28.12 Лада; 30.12 Барыс; 13.01 Салават Юлаев; 15.01 ЦСКА; 26.01 Адмирал; 29.01 Трактор; 05.02 Автомобилист; 15.02 Трактор; 17.02 Ак Барс; 20.02 Сибирь; 22.02 Амур; 27.02 Металлург Мг; 09.03 Сибирь; 11.03 Торпедо; 13.03 Шанхайские Драконы. Интервал на матч — сумма зональных интервалов (квантили 10/90% остатков CatBoost на валидации по группам зон {1,2,8} / {3,4,5} / {6,7} и статусу продаж). Честная проверка leave-one-fold-out: накрыл 38 из 43 матчей (88%) при номинале 80%. Ширина — 35% прогноза у матчей в продаже, 42% у остальных. Прямой интервал по остатку суммы матча вдвое уже, но накрыл только 26 из 43 (60%): не учитывает межсезонный сдвиг. Зональные интервалы — ориентир: покрытие 69% при номинале 80%. «71–105 тыс.» — сумма нижних и верхних границ по 17 матчам. График без интервалов, с линией среднего сезона — reports/figures/04_test_forecast.png, показать по вопросу.</a:t>
             </a:r>
           </a:p>
           <a:p/>
@@ -4644,8 +4644,8 @@
         </p:blipFill>
         <p:spPr>
           <a:xfrm>
-            <a:off x="2949226" y="3357880"/>
-            <a:ext cx="6293241" cy="3042920"/>
+            <a:off x="610742" y="3357880"/>
+            <a:ext cx="10970209" cy="3042920"/>
           </a:xfrm>
           <a:prstGeom prst="rect">
             <a:avLst/>

</xml_diff>